<commit_message>
Update deck with team and corrected gap
Add the team members to the cover, correct the detection-delay gap
statement and sources on slides 3 and 14, and rebuild the PPTX and PDF.
</commit_message>
<xml_diff>
--- a/docs/deck/progress-review-1.pptx
+++ b/docs/deck/progress-review-1.pptx
@@ -125,14 +125,14 @@
   <p:extLst>
     <p:ext uri="{521415D9-36F7-43E2-AB2F-B90AF26B5E84}">
       <p14:sectionLst xmlns:p14="http://schemas.microsoft.com/office/powerpoint/2010/main">
-        <p14:section name="Problem and questions" id="{7f4650b6-293c-681a-f5a3-cd786112db0f}">
+        <p14:section name="Problem and questions" id="{56e4bbea-3ebc-1edf-9a22-69e3fb2234e6}">
           <p14:sldIdLst>
             <p14:sldId id="256"/>
             <p14:sldId id="257"/>
             <p14:sldId id="258"/>
           </p14:sldIdLst>
         </p14:section>
-        <p14:section name="Foundation" id="{19c54b1d-0a1d-1f9a-264c-ba9cfceeb1b3}">
+        <p14:section name="Foundation" id="{8f441eb2-1d3f-8b4b-b66f-371e6c244b5a}">
           <p14:sldIdLst>
             <p14:sldId id="259"/>
             <p14:sldId id="260"/>
@@ -141,7 +141,7 @@
             <p14:sldId id="263"/>
           </p14:sldIdLst>
         </p14:section>
-        <p14:section name="RQ1: Residual Koopman" id="{0eeb3cd5-ddb0-262c-3fb1-87817317c029}">
+        <p14:section name="RQ1: Residual Koopman" id="{ca267fb6-a571-5981-cdd0-8586ca791aa6}">
           <p14:sldIdLst>
             <p14:sldId id="264"/>
             <p14:sldId id="265"/>
@@ -150,7 +150,7 @@
             <p14:sldId id="268"/>
           </p14:sldIdLst>
         </p14:section>
-        <p14:section name="RQ2: Detection delay" id="{c2b60bd6-a9a8-fa40-a65e-963db527b99a}">
+        <p14:section name="RQ2: Detection delay" id="{f172050d-f3f2-47e0-4a05-be1f8a716b38}">
           <p14:sldIdLst>
             <p14:sldId id="269"/>
             <p14:sldId id="270"/>
@@ -158,7 +158,7 @@
             <p14:sldId id="272"/>
           </p14:sldIdLst>
         </p14:section>
-        <p14:section name="Plan and summary" id="{8357b40e-4264-d990-ab07-e4d4de2ddbe7}">
+        <p14:section name="Plan and summary" id="{321d7262-648b-fb50-da04-c6f783684499}">
           <p14:sldIdLst>
             <p14:sldId id="273"/>
             <p14:sldId id="274"/>
@@ -1624,7 +1624,7 @@
           <a:p>
             <a:r>
               <a:rPr lang="en-US" dirty="0"/>
-              <a:t>When one rotor dies, a quadrotor cannot hover level any more. Mueller and D'Andrea showed it can still fly by spinning steadily about a tilted axis, called the relaxed hover. But there is a gap in time: the fault detector needs some time tau to notice the failure. During that time the normal controller keeps flying a vehicle that has lost a rotor. Only after detection does the failure controller take over and try to capture the vehicle into the spinning state. All guarantee-based papers we found assume tau equals zero. The one published tolerance figure is empirical and for a different vehicle.</a:t>
+              <a:t>When one rotor dies, a quadrotor cannot hover level any more. Mueller and D'Andrea showed it can still fly by spinning steadily about a tilted axis, called the relaxed hover. But there is a gap in time: the fault detector needs some time tau to notice the failure. During that time the normal controller keeps flying a vehicle that has lost a rotor. Only after detection does the failure controller take over and try to capture the vehicle into the spinning state. Most guarantee-based papers assume tau equals zero. Başak and Prempain proved stability for a linear model with a fixed delay, but without thrust limits and without finding the largest tolerable delay. Fast detectors take 30 to 130 milliseconds.</a:t>
             </a:r>
             <a:endParaRPr lang="en-US" dirty="0"/>
           </a:p>
@@ -3139,7 +3139,7 @@
         <p:spPr>
           <a:xfrm>
             <a:off x="731520" y="5852160"/>
-            <a:ext cx="6400800" cy="365760"/>
+            <a:ext cx="7680960" cy="365760"/>
           </a:xfrm>
           <a:prstGeom prst="rect">
             <a:avLst/>
@@ -3160,7 +3160,7 @@
                   <a:schemeClr val="accent3"/>
                 </a:solidFill>
               </a:rPr>
-              <a:t>[Team member names]</a:t>
+              <a:t>Pranshu Kumar · Mudita Jain · Prashant Gupta · Aarush Singh Kushwaha</a:t>
             </a:r>
             <a:endParaRPr lang="en-US" sz="1600" dirty="0"/>
           </a:p>
@@ -5242,7 +5242,7 @@
                   <a:schemeClr val="accent3"/>
                 </a:solidFill>
               </a:rPr>
-              <a:t>Recovery methods assume the failure is detected instantly. Real detectors take 30–130 ms.</a:t>
+              <a:t>Most recovery methods assume instant detection. Fast detectors take 30–130 ms.</a:t>
             </a:r>
             <a:endParaRPr lang="en-US" sz="2000" dirty="0"/>
           </a:p>
@@ -9169,7 +9169,7 @@
                   <a:schemeClr val="tx2"/>
                 </a:solidFill>
               </a:rPr>
-              <a:t>Every recovery method with a guarantee that we found assumes τ = 0.</a:t>
+              <a:t>Most recovery methods with a guarantee assume τ = 0.</a:t>
             </a:r>
             <a:endParaRPr lang="en-US" sz="1600" dirty="0"/>
           </a:p>
@@ -9186,7 +9186,7 @@
                   <a:schemeClr val="tx1"/>
                 </a:solidFill>
               </a:rPr>
-              <a:t>The only published tolerance (180 ms) comes from simulation sweeps on a different vehicle.</a:t>
+              <a:t>Stability with a fixed delay is shown for a linear model; a certified maximum delay under thrust limits was not found.</a:t>
             </a:r>
             <a:endParaRPr lang="en-US" sz="1600" dirty="0"/>
           </a:p>
@@ -9222,7 +9222,7 @@
                   <a:schemeClr val="accent6"/>
                 </a:solidFill>
               </a:rPr>
-              <a:t>Mueller &amp; D'Andrea 2014; Simha et al. 2017; Al Lawati &amp; Akhtar 2026; Kulkarni et al. (heli-quad)</a:t>
+              <a:t>Simha et al. 2017; Al Lawati &amp; Akhtar 2026; Başak &amp; Prempain 2015; Strack van Schijndel et al. 2021</a:t>
             </a:r>
             <a:endParaRPr lang="en-US" sz="1200" dirty="0"/>
           </a:p>

</xml_diff>